<commit_message>
docs: point presentation to submission repository
</commit_message>
<xml_diff>
--- a/Smart_Computer_Health_Monitor.pptx
+++ b/Smart_Computer_Health_Monitor.pptx
@@ -3368,7 +3368,7 @@
                 </a:solidFill>
                 <a:latin typeface="Arial"/>
               </a:rPr>
-              <a:t>GitHub: https://github.com/ranjansuman-collab/Smart-Computer-Health-Monitor</a:t>
+              <a:t>GitHub: https://github.com/doomsday-the/Smart-Computer-Health-Monitor</a:t>
             </a:r>
           </a:p>
         </p:txBody>
@@ -11864,7 +11864,7 @@
                 </a:solidFill>
                 <a:latin typeface="Arial"/>
               </a:rPr>
-              <a:t>GitHub: https://github.com/ranjansuman-collab/Smart-Computer-Health-Monitor</a:t>
+              <a:t>GitHub: https://github.com/doomsday-the/Smart-Computer-Health-Monitor</a:t>
             </a:r>
           </a:p>
         </p:txBody>

</xml_diff>